<commit_message>
Update presentation generator with 4K Retina slide renders for 100% pixel-perfect Keynote import
</commit_message>
<xml_diff>
--- a/OmniSearch_Presentation.pptx
+++ b/OmniSearch_Presentation.pptx
@@ -3090,14 +3090,6 @@
 <file path=ppt/slides/slide1.xml><?xml version="1.0" encoding="utf-8"?>
 <p:sld xmlns:a="http://schemas.openxmlformats.org/drawingml/2006/main" xmlns:p="http://schemas.openxmlformats.org/presentationml/2006/main" xmlns:r="http://schemas.openxmlformats.org/officeDocument/2006/relationships">
   <p:cSld>
-    <p:bg>
-      <p:bgPr>
-        <a:solidFill>
-          <a:srgbClr val="000000"/>
-        </a:solidFill>
-        <a:effectLst/>
-      </p:bgPr>
-    </p:bg>
     <p:spTree>
       <p:nvGrpSpPr>
         <p:cNvPr id="1" name=""/>
@@ -3105,91 +3097,30 @@
         <p:nvPr/>
       </p:nvGrpSpPr>
       <p:grpSpPr/>
-      <p:sp>
-        <p:nvSpPr>
-          <p:cNvPr id="2" name="TextBox 1"/>
-          <p:cNvSpPr txBox="1"/>
+      <p:pic>
+        <p:nvPicPr>
+          <p:cNvPr id="2" name="Picture 1" descr="slide_01.png"/>
+          <p:cNvPicPr>
+            <a:picLocks noChangeAspect="1"/>
+          </p:cNvPicPr>
           <p:nvPr/>
-        </p:nvSpPr>
+        </p:nvPicPr>
+        <p:blipFill>
+          <a:blip r:embed="rId2"/>
+          <a:stretch>
+            <a:fillRect/>
+          </a:stretch>
+        </p:blipFill>
         <p:spPr>
           <a:xfrm>
-            <a:off x="914400" y="2286000"/>
-            <a:ext cx="10332720" cy="1828800"/>
+            <a:off x="0" y="0"/>
+            <a:ext cx="12191695" cy="6858000"/>
           </a:xfrm>
           <a:prstGeom prst="rect">
             <a:avLst/>
           </a:prstGeom>
-          <a:noFill/>
         </p:spPr>
-        <p:txBody>
-          <a:bodyPr wrap="none">
-            <a:spAutoFit/>
-          </a:bodyPr>
-          <a:lstStyle/>
-          <a:p>
-            <a:pPr algn="l">
-              <a:defRPr sz="6400" b="1">
-                <a:solidFill>
-                  <a:srgbClr val="FFFFFF"/>
-                </a:solidFill>
-                <a:latin typeface="Arial"/>
-              </a:defRPr>
-            </a:pPr>
-            <a:r>
-              <a:t>Omni Search</a:t>
-            </a:r>
-          </a:p>
-          <a:p>
-            <a:pPr algn="l">
-              <a:defRPr sz="2800">
-                <a:solidFill>
-                  <a:srgbClr val="2997FF"/>
-                </a:solidFill>
-                <a:latin typeface="Arial"/>
-              </a:defRPr>
-            </a:pPr>
-            <a:r>
-              <a:t>Search at the speed of thought.</a:t>
-            </a:r>
-          </a:p>
-        </p:txBody>
-      </p:sp>
-      <p:sp>
-        <p:nvSpPr>
-          <p:cNvPr id="3" name="TextBox 2"/>
-          <p:cNvSpPr txBox="1"/>
-          <p:nvPr/>
-        </p:nvSpPr>
-        <p:spPr>
-          <a:xfrm>
-            <a:off x="8229600" y="5669280"/>
-            <a:ext cx="3200400" cy="548640"/>
-          </a:xfrm>
-          <a:prstGeom prst="rect">
-            <a:avLst/>
-          </a:prstGeom>
-          <a:noFill/>
-        </p:spPr>
-        <p:txBody>
-          <a:bodyPr wrap="none">
-            <a:spAutoFit/>
-          </a:bodyPr>
-          <a:lstStyle/>
-          <a:p>
-            <a:pPr algn="r">
-              <a:defRPr sz="1400">
-                <a:solidFill>
-                  <a:srgbClr val="86868B"/>
-                </a:solidFill>
-                <a:latin typeface="Arial"/>
-              </a:defRPr>
-            </a:pPr>
-            <a:r>
-              <a:t>Presented by Arun Thomas</a:t>
-            </a:r>
-          </a:p>
-        </p:txBody>
-      </p:sp>
+      </p:pic>
     </p:spTree>
   </p:cSld>
   <p:clrMapOvr>
@@ -3201,14 +3132,6 @@
 <file path=ppt/slides/slide10.xml><?xml version="1.0" encoding="utf-8"?>
 <p:sld xmlns:a="http://schemas.openxmlformats.org/drawingml/2006/main" xmlns:p="http://schemas.openxmlformats.org/presentationml/2006/main" xmlns:r="http://schemas.openxmlformats.org/officeDocument/2006/relationships">
   <p:cSld>
-    <p:bg>
-      <p:bgPr>
-        <a:solidFill>
-          <a:srgbClr val="000000"/>
-        </a:solidFill>
-        <a:effectLst/>
-      </p:bgPr>
-    </p:bg>
     <p:spTree>
       <p:nvGrpSpPr>
         <p:cNvPr id="1" name=""/>
@@ -3216,246 +3139,30 @@
         <p:nvPr/>
       </p:nvGrpSpPr>
       <p:grpSpPr/>
-      <p:sp>
-        <p:nvSpPr>
-          <p:cNvPr id="2" name="TextBox 1"/>
-          <p:cNvSpPr txBox="1"/>
+      <p:pic>
+        <p:nvPicPr>
+          <p:cNvPr id="2" name="Picture 1" descr="slide_10.png"/>
+          <p:cNvPicPr>
+            <a:picLocks noChangeAspect="1"/>
+          </p:cNvPicPr>
           <p:nvPr/>
-        </p:nvSpPr>
+        </p:nvPicPr>
+        <p:blipFill>
+          <a:blip r:embed="rId2"/>
+          <a:stretch>
+            <a:fillRect/>
+          </a:stretch>
+        </p:blipFill>
         <p:spPr>
           <a:xfrm>
-            <a:off x="731520" y="457200"/>
-            <a:ext cx="10698480" cy="365760"/>
+            <a:off x="0" y="0"/>
+            <a:ext cx="12191695" cy="6858000"/>
           </a:xfrm>
           <a:prstGeom prst="rect">
             <a:avLst/>
           </a:prstGeom>
-          <a:noFill/>
         </p:spPr>
-        <p:txBody>
-          <a:bodyPr wrap="square">
-            <a:spAutoFit/>
-          </a:bodyPr>
-          <a:lstStyle/>
-          <a:p>
-            <a:pPr>
-              <a:defRPr sz="1100" b="1">
-                <a:solidFill>
-                  <a:srgbClr val="2997FF"/>
-                </a:solidFill>
-                <a:latin typeface="Arial"/>
-              </a:defRPr>
-            </a:pPr>
-            <a:r>
-              <a:t>RELEASES</a:t>
-            </a:r>
-          </a:p>
-        </p:txBody>
-      </p:sp>
-      <p:sp>
-        <p:nvSpPr>
-          <p:cNvPr id="3" name="TextBox 2"/>
-          <p:cNvSpPr txBox="1"/>
-          <p:nvPr/>
-        </p:nvSpPr>
-        <p:spPr>
-          <a:xfrm>
-            <a:off x="731520" y="822960"/>
-            <a:ext cx="10698480" cy="731520"/>
-          </a:xfrm>
-          <a:prstGeom prst="rect">
-            <a:avLst/>
-          </a:prstGeom>
-          <a:noFill/>
-        </p:spPr>
-        <p:txBody>
-          <a:bodyPr wrap="square">
-            <a:spAutoFit/>
-          </a:bodyPr>
-          <a:lstStyle/>
-          <a:p>
-            <a:pPr>
-              <a:defRPr sz="3200" b="1">
-                <a:solidFill>
-                  <a:srgbClr val="FFFFFF"/>
-                </a:solidFill>
-                <a:latin typeface="Arial"/>
-              </a:defRPr>
-            </a:pPr>
-            <a:r>
-              <a:t>Select Your Version</a:t>
-            </a:r>
-          </a:p>
-        </p:txBody>
-      </p:sp>
-      <p:sp>
-        <p:nvSpPr>
-          <p:cNvPr id="4" name="Rounded Rectangle 3"/>
-          <p:cNvSpPr/>
-          <p:nvPr/>
-        </p:nvSpPr>
-        <p:spPr>
-          <a:xfrm>
-            <a:off x="1371600" y="2011680"/>
-            <a:ext cx="4389120" cy="3840480"/>
-          </a:xfrm>
-          <a:prstGeom prst="roundRect">
-            <a:avLst/>
-          </a:prstGeom>
-          <a:solidFill>
-            <a:srgbClr val="111111"/>
-          </a:solidFill>
-          <a:ln>
-            <a:solidFill>
-              <a:srgbClr val="2997FF"/>
-            </a:solidFill>
-          </a:ln>
-        </p:spPr>
-        <p:style>
-          <a:lnRef idx="1">
-            <a:schemeClr val="accent1"/>
-          </a:lnRef>
-          <a:fillRef idx="3">
-            <a:schemeClr val="accent1"/>
-          </a:fillRef>
-          <a:effectRef idx="2">
-            <a:schemeClr val="accent1"/>
-          </a:effectRef>
-          <a:fontRef idx="minor">
-            <a:schemeClr val="lt1"/>
-          </a:fontRef>
-        </p:style>
-        <p:txBody>
-          <a:bodyPr rtlCol="0" anchor="ctr" lIns="365760" tIns="457200" wrap="square"/>
-          <a:lstStyle/>
-          <a:p>
-            <a:pPr algn="ctr">
-              <a:spcAft>
-                <a:spcPts val="600"/>
-              </a:spcAft>
-              <a:defRPr sz="2400" b="1">
-                <a:solidFill>
-                  <a:srgbClr val="FFFFFF"/>
-                </a:solidFill>
-              </a:defRPr>
-            </a:pPr>
-            <a:r>
-              <a:t>v1.1 (Latest Release)</a:t>
-            </a:r>
-          </a:p>
-          <a:p>
-            <a:pPr>
-              <a:defRPr sz="1600">
-                <a:solidFill>
-                  <a:srgbClr val="2997FF"/>
-                </a:solidFill>
-              </a:defRPr>
-            </a:pPr>
-            <a:r>
-              <a:t>With Auto-Updater</a:t>
-            </a:r>
-          </a:p>
-          <a:p>
-            <a:pPr>
-              <a:spcBef>
-                <a:spcPts val="1400"/>
-              </a:spcBef>
-              <a:defRPr sz="1400">
-                <a:solidFill>
-                  <a:srgbClr val="86868B"/>
-                </a:solidFill>
-              </a:defRPr>
-            </a:pPr>
-            <a:r>
-              <a:t>Silent background update checks, link sanitizer, and PID tracking.</a:t>
-            </a:r>
-          </a:p>
-        </p:txBody>
-      </p:sp>
-      <p:sp>
-        <p:nvSpPr>
-          <p:cNvPr id="5" name="Rounded Rectangle 4"/>
-          <p:cNvSpPr/>
-          <p:nvPr/>
-        </p:nvSpPr>
-        <p:spPr>
-          <a:xfrm>
-            <a:off x="6126480" y="2011680"/>
-            <a:ext cx="4389120" cy="3840480"/>
-          </a:xfrm>
-          <a:prstGeom prst="roundRect">
-            <a:avLst/>
-          </a:prstGeom>
-          <a:solidFill>
-            <a:srgbClr val="111111"/>
-          </a:solidFill>
-          <a:ln>
-            <a:solidFill>
-              <a:srgbClr val="282828"/>
-            </a:solidFill>
-          </a:ln>
-        </p:spPr>
-        <p:style>
-          <a:lnRef idx="1">
-            <a:schemeClr val="accent1"/>
-          </a:lnRef>
-          <a:fillRef idx="3">
-            <a:schemeClr val="accent1"/>
-          </a:fillRef>
-          <a:effectRef idx="2">
-            <a:schemeClr val="accent1"/>
-          </a:effectRef>
-          <a:fontRef idx="minor">
-            <a:schemeClr val="lt1"/>
-          </a:fontRef>
-        </p:style>
-        <p:txBody>
-          <a:bodyPr rtlCol="0" anchor="ctr" lIns="365760" tIns="457200" wrap="square"/>
-          <a:lstStyle/>
-          <a:p>
-            <a:pPr algn="ctr">
-              <a:spcAft>
-                <a:spcPts val="600"/>
-              </a:spcAft>
-              <a:defRPr sz="2400" b="1">
-                <a:solidFill>
-                  <a:srgbClr val="FFFFFF"/>
-                </a:solidFill>
-              </a:defRPr>
-            </a:pPr>
-            <a:r>
-              <a:t>v1.0 (Stable Release)</a:t>
-            </a:r>
-          </a:p>
-          <a:p>
-            <a:pPr>
-              <a:defRPr sz="1600">
-                <a:solidFill>
-                  <a:srgbClr val="2997FF"/>
-                </a:solidFill>
-              </a:defRPr>
-            </a:pPr>
-            <a:r>
-              <a:t>Safe &amp; Production Ready</a:t>
-            </a:r>
-          </a:p>
-          <a:p>
-            <a:pPr>
-              <a:spcBef>
-                <a:spcPts val="1400"/>
-              </a:spcBef>
-              <a:defRPr sz="1400">
-                <a:solidFill>
-                  <a:srgbClr val="86868B"/>
-                </a:solidFill>
-              </a:defRPr>
-            </a:pPr>
-            <a:r>
-              <a:t>Original Omni Search native experience with manual updates.</a:t>
-            </a:r>
-          </a:p>
-        </p:txBody>
-      </p:sp>
+      </p:pic>
     </p:spTree>
   </p:cSld>
   <p:clrMapOvr>
@@ -3467,14 +3174,6 @@
 <file path=ppt/slides/slide2.xml><?xml version="1.0" encoding="utf-8"?>
 <p:sld xmlns:a="http://schemas.openxmlformats.org/drawingml/2006/main" xmlns:p="http://schemas.openxmlformats.org/presentationml/2006/main" xmlns:r="http://schemas.openxmlformats.org/officeDocument/2006/relationships">
   <p:cSld>
-    <p:bg>
-      <p:bgPr>
-        <a:solidFill>
-          <a:srgbClr val="000000"/>
-        </a:solidFill>
-        <a:effectLst/>
-      </p:bgPr>
-    </p:bg>
     <p:spTree>
       <p:nvGrpSpPr>
         <p:cNvPr id="1" name=""/>
@@ -3482,285 +3181,30 @@
         <p:nvPr/>
       </p:nvGrpSpPr>
       <p:grpSpPr/>
-      <p:sp>
-        <p:nvSpPr>
-          <p:cNvPr id="2" name="TextBox 1"/>
-          <p:cNvSpPr txBox="1"/>
+      <p:pic>
+        <p:nvPicPr>
+          <p:cNvPr id="2" name="Picture 1" descr="slide_02.png"/>
+          <p:cNvPicPr>
+            <a:picLocks noChangeAspect="1"/>
+          </p:cNvPicPr>
           <p:nvPr/>
-        </p:nvSpPr>
+        </p:nvPicPr>
+        <p:blipFill>
+          <a:blip r:embed="rId2"/>
+          <a:stretch>
+            <a:fillRect/>
+          </a:stretch>
+        </p:blipFill>
         <p:spPr>
           <a:xfrm>
-            <a:off x="731520" y="457200"/>
-            <a:ext cx="10698480" cy="365760"/>
+            <a:off x="0" y="0"/>
+            <a:ext cx="12191695" cy="6858000"/>
           </a:xfrm>
           <a:prstGeom prst="rect">
             <a:avLst/>
           </a:prstGeom>
-          <a:noFill/>
         </p:spPr>
-        <p:txBody>
-          <a:bodyPr wrap="square">
-            <a:spAutoFit/>
-          </a:bodyPr>
-          <a:lstStyle/>
-          <a:p>
-            <a:pPr>
-              <a:defRPr sz="1100" b="1">
-                <a:solidFill>
-                  <a:srgbClr val="2997FF"/>
-                </a:solidFill>
-                <a:latin typeface="Arial"/>
-              </a:defRPr>
-            </a:pPr>
-            <a:r>
-              <a:t>01 PROBLEM STATEMENT</a:t>
-            </a:r>
-          </a:p>
-        </p:txBody>
-      </p:sp>
-      <p:sp>
-        <p:nvSpPr>
-          <p:cNvPr id="3" name="TextBox 2"/>
-          <p:cNvSpPr txBox="1"/>
-          <p:nvPr/>
-        </p:nvSpPr>
-        <p:spPr>
-          <a:xfrm>
-            <a:off x="731520" y="822960"/>
-            <a:ext cx="10698480" cy="731520"/>
-          </a:xfrm>
-          <a:prstGeom prst="rect">
-            <a:avLst/>
-          </a:prstGeom>
-          <a:noFill/>
-        </p:spPr>
-        <p:txBody>
-          <a:bodyPr wrap="square">
-            <a:spAutoFit/>
-          </a:bodyPr>
-          <a:lstStyle/>
-          <a:p>
-            <a:pPr>
-              <a:defRPr sz="3200" b="1">
-                <a:solidFill>
-                  <a:srgbClr val="FFFFFF"/>
-                </a:solidFill>
-                <a:latin typeface="Arial"/>
-              </a:defRPr>
-            </a:pPr>
-            <a:r>
-              <a:t>The daily struggle is real.</a:t>
-            </a:r>
-          </a:p>
-        </p:txBody>
-      </p:sp>
-      <p:sp>
-        <p:nvSpPr>
-          <p:cNvPr id="4" name="Rounded Rectangle 3"/>
-          <p:cNvSpPr/>
-          <p:nvPr/>
-        </p:nvSpPr>
-        <p:spPr>
-          <a:xfrm>
-            <a:off x="731520" y="1828800"/>
-            <a:ext cx="3383280" cy="4114800"/>
-          </a:xfrm>
-          <a:prstGeom prst="roundRect">
-            <a:avLst/>
-          </a:prstGeom>
-          <a:solidFill>
-            <a:srgbClr val="111111"/>
-          </a:solidFill>
-          <a:ln>
-            <a:solidFill>
-              <a:srgbClr val="282828"/>
-            </a:solidFill>
-          </a:ln>
-        </p:spPr>
-        <p:style>
-          <a:lnRef idx="1">
-            <a:schemeClr val="accent1"/>
-          </a:lnRef>
-          <a:fillRef idx="3">
-            <a:schemeClr val="accent1"/>
-          </a:fillRef>
-          <a:effectRef idx="2">
-            <a:schemeClr val="accent1"/>
-          </a:effectRef>
-          <a:fontRef idx="minor">
-            <a:schemeClr val="lt1"/>
-          </a:fontRef>
-        </p:style>
-        <p:txBody>
-          <a:bodyPr rtlCol="0" anchor="ctr" lIns="274320" tIns="365760" rIns="274320" wrap="square"/>
-          <a:lstStyle/>
-          <a:p>
-            <a:pPr algn="ctr">
-              <a:spcAft>
-                <a:spcPts val="1400"/>
-              </a:spcAft>
-              <a:defRPr sz="2000" b="1">
-                <a:solidFill>
-                  <a:srgbClr val="FFFFFF"/>
-                </a:solidFill>
-              </a:defRPr>
-            </a:pPr>
-            <a:r>
-              <a:t>Context-Switching Tax</a:t>
-            </a:r>
-          </a:p>
-          <a:p>
-            <a:pPr>
-              <a:defRPr sz="1400">
-                <a:solidFill>
-                  <a:srgbClr val="86868B"/>
-                </a:solidFill>
-              </a:defRPr>
-            </a:pPr>
-            <a:r>
-              <a:t>Every search requires leaving the current app, opening a browser, navigating to the right tool, typing the query, and switching back. Analysts lose 5–15 minutes per day to this invisible friction.</a:t>
-            </a:r>
-          </a:p>
-        </p:txBody>
-      </p:sp>
-      <p:sp>
-        <p:nvSpPr>
-          <p:cNvPr id="5" name="Rounded Rectangle 4"/>
-          <p:cNvSpPr/>
-          <p:nvPr/>
-        </p:nvSpPr>
-        <p:spPr>
-          <a:xfrm>
-            <a:off x="4297680" y="1828800"/>
-            <a:ext cx="3383280" cy="4114800"/>
-          </a:xfrm>
-          <a:prstGeom prst="roundRect">
-            <a:avLst/>
-          </a:prstGeom>
-          <a:solidFill>
-            <a:srgbClr val="111111"/>
-          </a:solidFill>
-          <a:ln>
-            <a:solidFill>
-              <a:srgbClr val="282828"/>
-            </a:solidFill>
-          </a:ln>
-        </p:spPr>
-        <p:style>
-          <a:lnRef idx="1">
-            <a:schemeClr val="accent1"/>
-          </a:lnRef>
-          <a:fillRef idx="3">
-            <a:schemeClr val="accent1"/>
-          </a:fillRef>
-          <a:effectRef idx="2">
-            <a:schemeClr val="accent1"/>
-          </a:effectRef>
-          <a:fontRef idx="minor">
-            <a:schemeClr val="lt1"/>
-          </a:fontRef>
-        </p:style>
-        <p:txBody>
-          <a:bodyPr rtlCol="0" anchor="ctr" lIns="274320" tIns="365760" rIns="274320" wrap="square"/>
-          <a:lstStyle/>
-          <a:p>
-            <a:pPr algn="ctr">
-              <a:spcAft>
-                <a:spcPts val="1400"/>
-              </a:spcAft>
-              <a:defRPr sz="2000" b="1">
-                <a:solidFill>
-                  <a:srgbClr val="FFFFFF"/>
-                </a:solidFill>
-              </a:defRPr>
-            </a:pPr>
-            <a:r>
-              <a:t>Tab Overload</a:t>
-            </a:r>
-          </a:p>
-          <a:p>
-            <a:pPr>
-              <a:defRPr sz="1400">
-                <a:solidFill>
-                  <a:srgbClr val="86868B"/>
-                </a:solidFill>
-              </a:defRPr>
-            </a:pPr>
-            <a:r>
-              <a:t>No standardized search workflow. Each analyst uses different tools and methods, leading to browser clutter, lost tabs, and fragmented knowledge across dozens of open windows.</a:t>
-            </a:r>
-          </a:p>
-        </p:txBody>
-      </p:sp>
-      <p:sp>
-        <p:nvSpPr>
-          <p:cNvPr id="6" name="Rounded Rectangle 5"/>
-          <p:cNvSpPr/>
-          <p:nvPr/>
-        </p:nvSpPr>
-        <p:spPr>
-          <a:xfrm>
-            <a:off x="7863840" y="1828800"/>
-            <a:ext cx="3383280" cy="4114800"/>
-          </a:xfrm>
-          <a:prstGeom prst="roundRect">
-            <a:avLst/>
-          </a:prstGeom>
-          <a:solidFill>
-            <a:srgbClr val="111111"/>
-          </a:solidFill>
-          <a:ln>
-            <a:solidFill>
-              <a:srgbClr val="282828"/>
-            </a:solidFill>
-          </a:ln>
-        </p:spPr>
-        <p:style>
-          <a:lnRef idx="1">
-            <a:schemeClr val="accent1"/>
-          </a:lnRef>
-          <a:fillRef idx="3">
-            <a:schemeClr val="accent1"/>
-          </a:fillRef>
-          <a:effectRef idx="2">
-            <a:schemeClr val="accent1"/>
-          </a:effectRef>
-          <a:fontRef idx="minor">
-            <a:schemeClr val="lt1"/>
-          </a:fontRef>
-        </p:style>
-        <p:txBody>
-          <a:bodyPr rtlCol="0" anchor="ctr" lIns="274320" tIns="365760" rIns="274320" wrap="square"/>
-          <a:lstStyle/>
-          <a:p>
-            <a:pPr algn="ctr">
-              <a:spcAft>
-                <a:spcPts val="1400"/>
-              </a:spcAft>
-              <a:defRPr sz="2000" b="1">
-                <a:solidFill>
-                  <a:srgbClr val="FFFFFF"/>
-                </a:solidFill>
-              </a:defRPr>
-            </a:pPr>
-            <a:r>
-              <a:t>Accessibility Gap</a:t>
-            </a:r>
-          </a:p>
-          <a:p>
-            <a:pPr>
-              <a:defRPr sz="1400">
-                <a:solidFill>
-                  <a:srgbClr val="86868B"/>
-                </a:solidFill>
-              </a:defRPr>
-            </a:pPr>
-            <a:r>
-              <a:t>Specially-abled and blind analysts face an amplified burden — multi-step, mouse-dependent search workflows are a barrier. A keyboard-first, VoiceOver-compatible solution is essential.</a:t>
-            </a:r>
-          </a:p>
-        </p:txBody>
-      </p:sp>
+      </p:pic>
     </p:spTree>
   </p:cSld>
   <p:clrMapOvr>
@@ -3772,14 +3216,6 @@
 <file path=ppt/slides/slide3.xml><?xml version="1.0" encoding="utf-8"?>
 <p:sld xmlns:a="http://schemas.openxmlformats.org/drawingml/2006/main" xmlns:p="http://schemas.openxmlformats.org/presentationml/2006/main" xmlns:r="http://schemas.openxmlformats.org/officeDocument/2006/relationships">
   <p:cSld>
-    <p:bg>
-      <p:bgPr>
-        <a:solidFill>
-          <a:srgbClr val="000000"/>
-        </a:solidFill>
-        <a:effectLst/>
-      </p:bgPr>
-    </p:bg>
     <p:spTree>
       <p:nvGrpSpPr>
         <p:cNvPr id="1" name=""/>
@@ -3787,275 +3223,30 @@
         <p:nvPr/>
       </p:nvGrpSpPr>
       <p:grpSpPr/>
-      <p:sp>
-        <p:nvSpPr>
-          <p:cNvPr id="2" name="TextBox 1"/>
-          <p:cNvSpPr txBox="1"/>
+      <p:pic>
+        <p:nvPicPr>
+          <p:cNvPr id="2" name="Picture 1" descr="slide_03.png"/>
+          <p:cNvPicPr>
+            <a:picLocks noChangeAspect="1"/>
+          </p:cNvPicPr>
           <p:nvPr/>
-        </p:nvSpPr>
+        </p:nvPicPr>
+        <p:blipFill>
+          <a:blip r:embed="rId2"/>
+          <a:stretch>
+            <a:fillRect/>
+          </a:stretch>
+        </p:blipFill>
         <p:spPr>
           <a:xfrm>
-            <a:off x="731520" y="457200"/>
-            <a:ext cx="10698480" cy="365760"/>
+            <a:off x="0" y="0"/>
+            <a:ext cx="12191695" cy="6858000"/>
           </a:xfrm>
           <a:prstGeom prst="rect">
             <a:avLst/>
           </a:prstGeom>
-          <a:noFill/>
         </p:spPr>
-        <p:txBody>
-          <a:bodyPr wrap="square">
-            <a:spAutoFit/>
-          </a:bodyPr>
-          <a:lstStyle/>
-          <a:p>
-            <a:pPr>
-              <a:defRPr sz="1100" b="1">
-                <a:solidFill>
-                  <a:srgbClr val="2997FF"/>
-                </a:solidFill>
-                <a:latin typeface="Arial"/>
-              </a:defRPr>
-            </a:pPr>
-            <a:r>
-              <a:t>02 OBJECTIVE</a:t>
-            </a:r>
-          </a:p>
-        </p:txBody>
-      </p:sp>
-      <p:sp>
-        <p:nvSpPr>
-          <p:cNvPr id="3" name="TextBox 2"/>
-          <p:cNvSpPr txBox="1"/>
-          <p:nvPr/>
-        </p:nvSpPr>
-        <p:spPr>
-          <a:xfrm>
-            <a:off x="731520" y="822960"/>
-            <a:ext cx="10698480" cy="731520"/>
-          </a:xfrm>
-          <a:prstGeom prst="rect">
-            <a:avLst/>
-          </a:prstGeom>
-          <a:noFill/>
-        </p:spPr>
-        <p:txBody>
-          <a:bodyPr wrap="square">
-            <a:spAutoFit/>
-          </a:bodyPr>
-          <a:lstStyle/>
-          <a:p>
-            <a:pPr>
-              <a:defRPr sz="3200" b="1">
-                <a:solidFill>
-                  <a:srgbClr val="FFFFFF"/>
-                </a:solidFill>
-                <a:latin typeface="Arial"/>
-              </a:defRPr>
-            </a:pPr>
-            <a:r>
-              <a:t>Native, Zero-Friction &amp; Accessible</a:t>
-            </a:r>
-          </a:p>
-        </p:txBody>
-      </p:sp>
-      <p:sp>
-        <p:nvSpPr>
-          <p:cNvPr id="4" name="TextBox 3"/>
-          <p:cNvSpPr txBox="1"/>
-          <p:nvPr/>
-        </p:nvSpPr>
-        <p:spPr>
-          <a:xfrm>
-            <a:off x="914400" y="2011680"/>
-            <a:ext cx="10360152" cy="1645920"/>
-          </a:xfrm>
-          <a:prstGeom prst="rect">
-            <a:avLst/>
-          </a:prstGeom>
-          <a:noFill/>
-        </p:spPr>
-        <p:txBody>
-          <a:bodyPr wrap="square">
-            <a:spAutoFit/>
-          </a:bodyPr>
-          <a:lstStyle/>
-          <a:p>
-            <a:pPr algn="l">
-              <a:defRPr sz="2600">
-                <a:solidFill>
-                  <a:srgbClr val="FFFFFF"/>
-                </a:solidFill>
-              </a:defRPr>
-            </a:pPr>
-            <a:r>
-              <a:t>Build a native, zero-friction search utility that routes any selected text to the right tool — instantly — from any app, on any desktop, for every analyst.</a:t>
-            </a:r>
-          </a:p>
-        </p:txBody>
-      </p:sp>
-      <p:sp>
-        <p:nvSpPr>
-          <p:cNvPr id="5" name="Rounded Rectangle 4"/>
-          <p:cNvSpPr/>
-          <p:nvPr/>
-        </p:nvSpPr>
-        <p:spPr>
-          <a:xfrm>
-            <a:off x="914400" y="4114800"/>
-            <a:ext cx="3200400" cy="1645920"/>
-          </a:xfrm>
-          <a:prstGeom prst="roundRect">
-            <a:avLst/>
-          </a:prstGeom>
-          <a:solidFill>
-            <a:srgbClr val="111111"/>
-          </a:solidFill>
-          <a:ln>
-            <a:solidFill>
-              <a:srgbClr val="2997FF"/>
-            </a:solidFill>
-          </a:ln>
-        </p:spPr>
-        <p:style>
-          <a:lnRef idx="1">
-            <a:schemeClr val="accent1"/>
-          </a:lnRef>
-          <a:fillRef idx="3">
-            <a:schemeClr val="accent1"/>
-          </a:fillRef>
-          <a:effectRef idx="2">
-            <a:schemeClr val="accent1"/>
-          </a:effectRef>
-          <a:fontRef idx="minor">
-            <a:schemeClr val="lt1"/>
-          </a:fontRef>
-        </p:style>
-        <p:txBody>
-          <a:bodyPr rtlCol="0" anchor="ctr" wrap="square"/>
-          <a:lstStyle/>
-          <a:p>
-            <a:pPr algn="ctr">
-              <a:defRPr sz="2000" b="1">
-                <a:solidFill>
-                  <a:srgbClr val="2997FF"/>
-                </a:solidFill>
-              </a:defRPr>
-            </a:pPr>
-            <a:r>
-              <a:t>Zero Friction</a:t>
-            </a:r>
-          </a:p>
-        </p:txBody>
-      </p:sp>
-      <p:sp>
-        <p:nvSpPr>
-          <p:cNvPr id="6" name="Rounded Rectangle 5"/>
-          <p:cNvSpPr/>
-          <p:nvPr/>
-        </p:nvSpPr>
-        <p:spPr>
-          <a:xfrm>
-            <a:off x="4480560" y="4114800"/>
-            <a:ext cx="3200400" cy="1645920"/>
-          </a:xfrm>
-          <a:prstGeom prst="roundRect">
-            <a:avLst/>
-          </a:prstGeom>
-          <a:solidFill>
-            <a:srgbClr val="111111"/>
-          </a:solidFill>
-          <a:ln>
-            <a:solidFill>
-              <a:srgbClr val="30D158"/>
-            </a:solidFill>
-          </a:ln>
-        </p:spPr>
-        <p:style>
-          <a:lnRef idx="1">
-            <a:schemeClr val="accent1"/>
-          </a:lnRef>
-          <a:fillRef idx="3">
-            <a:schemeClr val="accent1"/>
-          </a:fillRef>
-          <a:effectRef idx="2">
-            <a:schemeClr val="accent1"/>
-          </a:effectRef>
-          <a:fontRef idx="minor">
-            <a:schemeClr val="lt1"/>
-          </a:fontRef>
-        </p:style>
-        <p:txBody>
-          <a:bodyPr rtlCol="0" anchor="ctr" wrap="square"/>
-          <a:lstStyle/>
-          <a:p>
-            <a:pPr algn="ctr">
-              <a:defRPr sz="2000" b="1">
-                <a:solidFill>
-                  <a:srgbClr val="30D158"/>
-                </a:solidFill>
-              </a:defRPr>
-            </a:pPr>
-            <a:r>
-              <a:t>Fully Accessible</a:t>
-            </a:r>
-          </a:p>
-        </p:txBody>
-      </p:sp>
-      <p:sp>
-        <p:nvSpPr>
-          <p:cNvPr id="7" name="Rounded Rectangle 6"/>
-          <p:cNvSpPr/>
-          <p:nvPr/>
-        </p:nvSpPr>
-        <p:spPr>
-          <a:xfrm>
-            <a:off x="8046720" y="4114800"/>
-            <a:ext cx="3200400" cy="1645920"/>
-          </a:xfrm>
-          <a:prstGeom prst="roundRect">
-            <a:avLst/>
-          </a:prstGeom>
-          <a:solidFill>
-            <a:srgbClr val="111111"/>
-          </a:solidFill>
-          <a:ln>
-            <a:solidFill>
-              <a:srgbClr val="BF5AF2"/>
-            </a:solidFill>
-          </a:ln>
-        </p:spPr>
-        <p:style>
-          <a:lnRef idx="1">
-            <a:schemeClr val="accent1"/>
-          </a:lnRef>
-          <a:fillRef idx="3">
-            <a:schemeClr val="accent1"/>
-          </a:fillRef>
-          <a:effectRef idx="2">
-            <a:schemeClr val="accent1"/>
-          </a:effectRef>
-          <a:fontRef idx="minor">
-            <a:schemeClr val="lt1"/>
-          </a:fontRef>
-        </p:style>
-        <p:txBody>
-          <a:bodyPr rtlCol="0" anchor="ctr" wrap="square"/>
-          <a:lstStyle/>
-          <a:p>
-            <a:pPr algn="ctr">
-              <a:defRPr sz="2000" b="1">
-                <a:solidFill>
-                  <a:srgbClr val="BF5AF2"/>
-                </a:solidFill>
-              </a:defRPr>
-            </a:pPr>
-            <a:r>
-              <a:t>Intelligent Routing</a:t>
-            </a:r>
-          </a:p>
-        </p:txBody>
-      </p:sp>
+      </p:pic>
     </p:spTree>
   </p:cSld>
   <p:clrMapOvr>
@@ -4067,14 +3258,6 @@
 <file path=ppt/slides/slide4.xml><?xml version="1.0" encoding="utf-8"?>
 <p:sld xmlns:a="http://schemas.openxmlformats.org/drawingml/2006/main" xmlns:p="http://schemas.openxmlformats.org/presentationml/2006/main" xmlns:r="http://schemas.openxmlformats.org/officeDocument/2006/relationships">
   <p:cSld>
-    <p:bg>
-      <p:bgPr>
-        <a:solidFill>
-          <a:srgbClr val="000000"/>
-        </a:solidFill>
-        <a:effectLst/>
-      </p:bgPr>
-    </p:bg>
     <p:spTree>
       <p:nvGrpSpPr>
         <p:cNvPr id="1" name=""/>
@@ -4082,320 +3265,30 @@
         <p:nvPr/>
       </p:nvGrpSpPr>
       <p:grpSpPr/>
-      <p:sp>
-        <p:nvSpPr>
-          <p:cNvPr id="2" name="TextBox 1"/>
-          <p:cNvSpPr txBox="1"/>
+      <p:pic>
+        <p:nvPicPr>
+          <p:cNvPr id="2" name="Picture 1" descr="slide_04.png"/>
+          <p:cNvPicPr>
+            <a:picLocks noChangeAspect="1"/>
+          </p:cNvPicPr>
           <p:nvPr/>
-        </p:nvSpPr>
+        </p:nvPicPr>
+        <p:blipFill>
+          <a:blip r:embed="rId2"/>
+          <a:stretch>
+            <a:fillRect/>
+          </a:stretch>
+        </p:blipFill>
         <p:spPr>
           <a:xfrm>
-            <a:off x="731520" y="457200"/>
-            <a:ext cx="10698480" cy="365760"/>
+            <a:off x="0" y="0"/>
+            <a:ext cx="12191695" cy="6858000"/>
           </a:xfrm>
           <a:prstGeom prst="rect">
             <a:avLst/>
           </a:prstGeom>
-          <a:noFill/>
         </p:spPr>
-        <p:txBody>
-          <a:bodyPr wrap="square">
-            <a:spAutoFit/>
-          </a:bodyPr>
-          <a:lstStyle/>
-          <a:p>
-            <a:pPr>
-              <a:defRPr sz="1100" b="1">
-                <a:solidFill>
-                  <a:srgbClr val="2997FF"/>
-                </a:solidFill>
-                <a:latin typeface="Arial"/>
-              </a:defRPr>
-            </a:pPr>
-            <a:r>
-              <a:t>03 SOLUTION</a:t>
-            </a:r>
-          </a:p>
-        </p:txBody>
-      </p:sp>
-      <p:sp>
-        <p:nvSpPr>
-          <p:cNvPr id="3" name="TextBox 2"/>
-          <p:cNvSpPr txBox="1"/>
-          <p:nvPr/>
-        </p:nvSpPr>
-        <p:spPr>
-          <a:xfrm>
-            <a:off x="731520" y="822960"/>
-            <a:ext cx="10698480" cy="731520"/>
-          </a:xfrm>
-          <a:prstGeom prst="rect">
-            <a:avLst/>
-          </a:prstGeom>
-          <a:noFill/>
-        </p:spPr>
-        <p:txBody>
-          <a:bodyPr wrap="square">
-            <a:spAutoFit/>
-          </a:bodyPr>
-          <a:lstStyle/>
-          <a:p>
-            <a:pPr>
-              <a:defRPr sz="3200" b="1">
-                <a:solidFill>
-                  <a:srgbClr val="FFFFFF"/>
-                </a:solidFill>
-                <a:latin typeface="Arial"/>
-              </a:defRPr>
-            </a:pPr>
-            <a:r>
-              <a:t>Omni Search. Absolute focus.</a:t>
-            </a:r>
-          </a:p>
-        </p:txBody>
-      </p:sp>
-      <p:sp>
-        <p:nvSpPr>
-          <p:cNvPr id="4" name="TextBox 3"/>
-          <p:cNvSpPr txBox="1"/>
-          <p:nvPr/>
-        </p:nvSpPr>
-        <p:spPr>
-          <a:xfrm>
-            <a:off x="731520" y="1645920"/>
-            <a:ext cx="10698480" cy="731520"/>
-          </a:xfrm>
-          <a:prstGeom prst="rect">
-            <a:avLst/>
-          </a:prstGeom>
-          <a:noFill/>
-        </p:spPr>
-        <p:txBody>
-          <a:bodyPr wrap="square">
-            <a:spAutoFit/>
-          </a:bodyPr>
-          <a:lstStyle/>
-          <a:p>
-            <a:pPr>
-              <a:defRPr sz="1600">
-                <a:solidFill>
-                  <a:srgbClr val="86868B"/>
-                </a:solidFill>
-              </a:defRPr>
-            </a:pPr>
-            <a:r>
-              <a:t>A native macOS shortcut utility that routes queries directly to your favorite tools, cleans search URLs automatically, and reuses open browser windows without distracting tab clutter.</a:t>
-            </a:r>
-          </a:p>
-        </p:txBody>
-      </p:sp>
-      <p:sp>
-        <p:nvSpPr>
-          <p:cNvPr id="5" name="Rounded Rectangle 4"/>
-          <p:cNvSpPr/>
-          <p:nvPr/>
-        </p:nvSpPr>
-        <p:spPr>
-          <a:xfrm>
-            <a:off x="731520" y="2560320"/>
-            <a:ext cx="3383280" cy="3474720"/>
-          </a:xfrm>
-          <a:prstGeom prst="roundRect">
-            <a:avLst/>
-          </a:prstGeom>
-          <a:solidFill>
-            <a:srgbClr val="111111"/>
-          </a:solidFill>
-          <a:ln>
-            <a:solidFill>
-              <a:srgbClr val="282828"/>
-            </a:solidFill>
-          </a:ln>
-        </p:spPr>
-        <p:style>
-          <a:lnRef idx="1">
-            <a:schemeClr val="accent1"/>
-          </a:lnRef>
-          <a:fillRef idx="3">
-            <a:schemeClr val="accent1"/>
-          </a:fillRef>
-          <a:effectRef idx="2">
-            <a:schemeClr val="accent1"/>
-          </a:effectRef>
-          <a:fontRef idx="minor">
-            <a:schemeClr val="lt1"/>
-          </a:fontRef>
-        </p:style>
-        <p:txBody>
-          <a:bodyPr rtlCol="0" anchor="ctr" lIns="274320" tIns="365760" wrap="square"/>
-          <a:lstStyle/>
-          <a:p>
-            <a:pPr algn="ctr">
-              <a:spcAft>
-                <a:spcPts val="1000"/>
-              </a:spcAft>
-              <a:defRPr sz="1800" b="1">
-                <a:solidFill>
-                  <a:srgbClr val="2997FF"/>
-                </a:solidFill>
-              </a:defRPr>
-            </a:pPr>
-            <a:r>
-              <a:t>Lightning Fast</a:t>
-            </a:r>
-          </a:p>
-          <a:p>
-            <a:pPr>
-              <a:defRPr sz="1400">
-                <a:solidFill>
-                  <a:srgbClr val="86868B"/>
-                </a:solidFill>
-              </a:defRPr>
-            </a:pPr>
-            <a:r>
-              <a:t>Reuses active windows instantly via precise window targeting.</a:t>
-            </a:r>
-          </a:p>
-        </p:txBody>
-      </p:sp>
-      <p:sp>
-        <p:nvSpPr>
-          <p:cNvPr id="6" name="Rounded Rectangle 5"/>
-          <p:cNvSpPr/>
-          <p:nvPr/>
-        </p:nvSpPr>
-        <p:spPr>
-          <a:xfrm>
-            <a:off x="4297680" y="2560320"/>
-            <a:ext cx="3383280" cy="3474720"/>
-          </a:xfrm>
-          <a:prstGeom prst="roundRect">
-            <a:avLst/>
-          </a:prstGeom>
-          <a:solidFill>
-            <a:srgbClr val="111111"/>
-          </a:solidFill>
-          <a:ln>
-            <a:solidFill>
-              <a:srgbClr val="282828"/>
-            </a:solidFill>
-          </a:ln>
-        </p:spPr>
-        <p:style>
-          <a:lnRef idx="1">
-            <a:schemeClr val="accent1"/>
-          </a:lnRef>
-          <a:fillRef idx="3">
-            <a:schemeClr val="accent1"/>
-          </a:fillRef>
-          <a:effectRef idx="2">
-            <a:schemeClr val="accent1"/>
-          </a:effectRef>
-          <a:fontRef idx="minor">
-            <a:schemeClr val="lt1"/>
-          </a:fontRef>
-        </p:style>
-        <p:txBody>
-          <a:bodyPr rtlCol="0" anchor="ctr" lIns="274320" tIns="365760" wrap="square"/>
-          <a:lstStyle/>
-          <a:p>
-            <a:pPr algn="ctr">
-              <a:spcAft>
-                <a:spcPts val="1000"/>
-              </a:spcAft>
-              <a:defRPr sz="1800" b="1">
-                <a:solidFill>
-                  <a:srgbClr val="2997FF"/>
-                </a:solidFill>
-              </a:defRPr>
-            </a:pPr>
-            <a:r>
-              <a:t>Smart Link Sanitizer</a:t>
-            </a:r>
-          </a:p>
-          <a:p>
-            <a:pPr>
-              <a:defRPr sz="1400">
-                <a:solidFill>
-                  <a:srgbClr val="86868B"/>
-                </a:solidFill>
-              </a:defRPr>
-            </a:pPr>
-            <a:r>
-              <a:t>Cleans and formats search URLs so they open smoothly in enterprise tools without security block errors.</a:t>
-            </a:r>
-          </a:p>
-        </p:txBody>
-      </p:sp>
-      <p:sp>
-        <p:nvSpPr>
-          <p:cNvPr id="7" name="Rounded Rectangle 6"/>
-          <p:cNvSpPr/>
-          <p:nvPr/>
-        </p:nvSpPr>
-        <p:spPr>
-          <a:xfrm>
-            <a:off x="7863840" y="2560320"/>
-            <a:ext cx="3383280" cy="3474720"/>
-          </a:xfrm>
-          <a:prstGeom prst="roundRect">
-            <a:avLst/>
-          </a:prstGeom>
-          <a:solidFill>
-            <a:srgbClr val="111111"/>
-          </a:solidFill>
-          <a:ln>
-            <a:solidFill>
-              <a:srgbClr val="282828"/>
-            </a:solidFill>
-          </a:ln>
-        </p:spPr>
-        <p:style>
-          <a:lnRef idx="1">
-            <a:schemeClr val="accent1"/>
-          </a:lnRef>
-          <a:fillRef idx="3">
-            <a:schemeClr val="accent1"/>
-          </a:fillRef>
-          <a:effectRef idx="2">
-            <a:schemeClr val="accent1"/>
-          </a:effectRef>
-          <a:fontRef idx="minor">
-            <a:schemeClr val="lt1"/>
-          </a:fontRef>
-        </p:style>
-        <p:txBody>
-          <a:bodyPr rtlCol="0" anchor="ctr" lIns="274320" tIns="365760" wrap="square"/>
-          <a:lstStyle/>
-          <a:p>
-            <a:pPr algn="ctr">
-              <a:spcAft>
-                <a:spcPts val="1000"/>
-              </a:spcAft>
-              <a:defRPr sz="1800" b="1">
-                <a:solidFill>
-                  <a:srgbClr val="2997FF"/>
-                </a:solidFill>
-              </a:defRPr>
-            </a:pPr>
-            <a:r>
-              <a:t>Instant Focus</a:t>
-            </a:r>
-          </a:p>
-          <a:p>
-            <a:pPr>
-              <a:defRPr sz="1400">
-                <a:solidFill>
-                  <a:srgbClr val="86868B"/>
-                </a:solidFill>
-              </a:defRPr>
-            </a:pPr>
-            <a:r>
-              <a:t>Pulls search results to the absolute front across all virtual desktops.</a:t>
-            </a:r>
-          </a:p>
-        </p:txBody>
-      </p:sp>
+      </p:pic>
     </p:spTree>
   </p:cSld>
   <p:clrMapOvr>
@@ -4407,14 +3300,6 @@
 <file path=ppt/slides/slide5.xml><?xml version="1.0" encoding="utf-8"?>
 <p:sld xmlns:a="http://schemas.openxmlformats.org/drawingml/2006/main" xmlns:p="http://schemas.openxmlformats.org/presentationml/2006/main" xmlns:r="http://schemas.openxmlformats.org/officeDocument/2006/relationships">
   <p:cSld>
-    <p:bg>
-      <p:bgPr>
-        <a:solidFill>
-          <a:srgbClr val="000000"/>
-        </a:solidFill>
-        <a:effectLst/>
-      </p:bgPr>
-    </p:bg>
     <p:spTree>
       <p:nvGrpSpPr>
         <p:cNvPr id="1" name=""/>
@@ -4422,330 +3307,30 @@
         <p:nvPr/>
       </p:nvGrpSpPr>
       <p:grpSpPr/>
-      <p:sp>
-        <p:nvSpPr>
-          <p:cNvPr id="2" name="TextBox 1"/>
-          <p:cNvSpPr txBox="1"/>
+      <p:pic>
+        <p:nvPicPr>
+          <p:cNvPr id="2" name="Picture 1" descr="slide_05.png"/>
+          <p:cNvPicPr>
+            <a:picLocks noChangeAspect="1"/>
+          </p:cNvPicPr>
           <p:nvPr/>
-        </p:nvSpPr>
+        </p:nvPicPr>
+        <p:blipFill>
+          <a:blip r:embed="rId2"/>
+          <a:stretch>
+            <a:fillRect/>
+          </a:stretch>
+        </p:blipFill>
         <p:spPr>
           <a:xfrm>
-            <a:off x="731520" y="457200"/>
-            <a:ext cx="10698480" cy="365760"/>
+            <a:off x="0" y="0"/>
+            <a:ext cx="12191695" cy="6858000"/>
           </a:xfrm>
           <a:prstGeom prst="rect">
             <a:avLst/>
           </a:prstGeom>
-          <a:noFill/>
         </p:spPr>
-        <p:txBody>
-          <a:bodyPr wrap="square">
-            <a:spAutoFit/>
-          </a:bodyPr>
-          <a:lstStyle/>
-          <a:p>
-            <a:pPr>
-              <a:defRPr sz="1100" b="1">
-                <a:solidFill>
-                  <a:srgbClr val="2997FF"/>
-                </a:solidFill>
-                <a:latin typeface="Arial"/>
-              </a:defRPr>
-            </a:pPr>
-            <a:r>
-              <a:t>03 SOLUTION</a:t>
-            </a:r>
-          </a:p>
-        </p:txBody>
-      </p:sp>
-      <p:sp>
-        <p:nvSpPr>
-          <p:cNvPr id="3" name="TextBox 2"/>
-          <p:cNvSpPr txBox="1"/>
-          <p:nvPr/>
-        </p:nvSpPr>
-        <p:spPr>
-          <a:xfrm>
-            <a:off x="731520" y="822960"/>
-            <a:ext cx="10698480" cy="731520"/>
-          </a:xfrm>
-          <a:prstGeom prst="rect">
-            <a:avLst/>
-          </a:prstGeom>
-          <a:noFill/>
-        </p:spPr>
-        <p:txBody>
-          <a:bodyPr wrap="square">
-            <a:spAutoFit/>
-          </a:bodyPr>
-          <a:lstStyle/>
-          <a:p>
-            <a:pPr>
-              <a:defRPr sz="3200" b="1">
-                <a:solidFill>
-                  <a:srgbClr val="FFFFFF"/>
-                </a:solidFill>
-                <a:latin typeface="Arial"/>
-              </a:defRPr>
-            </a:pPr>
-            <a:r>
-              <a:t>How does it work?</a:t>
-            </a:r>
-          </a:p>
-        </p:txBody>
-      </p:sp>
-      <p:sp>
-        <p:nvSpPr>
-          <p:cNvPr id="4" name="Rounded Rectangle 3"/>
-          <p:cNvSpPr/>
-          <p:nvPr/>
-        </p:nvSpPr>
-        <p:spPr>
-          <a:xfrm>
-            <a:off x="731520" y="2011680"/>
-            <a:ext cx="3383280" cy="3840480"/>
-          </a:xfrm>
-          <a:prstGeom prst="roundRect">
-            <a:avLst/>
-          </a:prstGeom>
-          <a:solidFill>
-            <a:srgbClr val="111111"/>
-          </a:solidFill>
-          <a:ln>
-            <a:solidFill>
-              <a:srgbClr val="282828"/>
-            </a:solidFill>
-          </a:ln>
-        </p:spPr>
-        <p:style>
-          <a:lnRef idx="1">
-            <a:schemeClr val="accent1"/>
-          </a:lnRef>
-          <a:fillRef idx="3">
-            <a:schemeClr val="accent1"/>
-          </a:fillRef>
-          <a:effectRef idx="2">
-            <a:schemeClr val="accent1"/>
-          </a:effectRef>
-          <a:fontRef idx="minor">
-            <a:schemeClr val="lt1"/>
-          </a:fontRef>
-        </p:style>
-        <p:txBody>
-          <a:bodyPr rtlCol="0" anchor="ctr" lIns="274320" tIns="365760" wrap="square"/>
-          <a:lstStyle/>
-          <a:p>
-            <a:pPr algn="ctr">
-              <a:spcAft>
-                <a:spcPts val="1000"/>
-              </a:spcAft>
-              <a:defRPr sz="3600" b="1">
-                <a:solidFill>
-                  <a:srgbClr val="2997FF"/>
-                </a:solidFill>
-              </a:defRPr>
-            </a:pPr>
-            <a:r>
-              <a:t>1</a:t>
-            </a:r>
-          </a:p>
-          <a:p>
-            <a:pPr>
-              <a:spcAft>
-                <a:spcPts val="1000"/>
-              </a:spcAft>
-              <a:defRPr sz="2200" b="1">
-                <a:solidFill>
-                  <a:srgbClr val="FFFFFF"/>
-                </a:solidFill>
-              </a:defRPr>
-            </a:pPr>
-            <a:r>
-              <a:t>Highlight</a:t>
-            </a:r>
-          </a:p>
-          <a:p>
-            <a:pPr>
-              <a:defRPr sz="1400">
-                <a:solidFill>
-                  <a:srgbClr val="86868B"/>
-                </a:solidFill>
-              </a:defRPr>
-            </a:pPr>
-            <a:r>
-              <a:t>Select any text, in any app, anywhere on your screen.</a:t>
-            </a:r>
-          </a:p>
-        </p:txBody>
-      </p:sp>
-      <p:sp>
-        <p:nvSpPr>
-          <p:cNvPr id="5" name="Rounded Rectangle 4"/>
-          <p:cNvSpPr/>
-          <p:nvPr/>
-        </p:nvSpPr>
-        <p:spPr>
-          <a:xfrm>
-            <a:off x="4297680" y="2011680"/>
-            <a:ext cx="3383280" cy="3840480"/>
-          </a:xfrm>
-          <a:prstGeom prst="roundRect">
-            <a:avLst/>
-          </a:prstGeom>
-          <a:solidFill>
-            <a:srgbClr val="111111"/>
-          </a:solidFill>
-          <a:ln>
-            <a:solidFill>
-              <a:srgbClr val="282828"/>
-            </a:solidFill>
-          </a:ln>
-        </p:spPr>
-        <p:style>
-          <a:lnRef idx="1">
-            <a:schemeClr val="accent1"/>
-          </a:lnRef>
-          <a:fillRef idx="3">
-            <a:schemeClr val="accent1"/>
-          </a:fillRef>
-          <a:effectRef idx="2">
-            <a:schemeClr val="accent1"/>
-          </a:effectRef>
-          <a:fontRef idx="minor">
-            <a:schemeClr val="lt1"/>
-          </a:fontRef>
-        </p:style>
-        <p:txBody>
-          <a:bodyPr rtlCol="0" anchor="ctr" lIns="274320" tIns="365760" wrap="square"/>
-          <a:lstStyle/>
-          <a:p>
-            <a:pPr algn="ctr">
-              <a:spcAft>
-                <a:spcPts val="1000"/>
-              </a:spcAft>
-              <a:defRPr sz="3600" b="1">
-                <a:solidFill>
-                  <a:srgbClr val="BF5AF2"/>
-                </a:solidFill>
-              </a:defRPr>
-            </a:pPr>
-            <a:r>
-              <a:t>2</a:t>
-            </a:r>
-          </a:p>
-          <a:p>
-            <a:pPr>
-              <a:spcAft>
-                <a:spcPts val="1000"/>
-              </a:spcAft>
-              <a:defRPr sz="2200" b="1">
-                <a:solidFill>
-                  <a:srgbClr val="FFFFFF"/>
-                </a:solidFill>
-              </a:defRPr>
-            </a:pPr>
-            <a:r>
-              <a:t>Trigger</a:t>
-            </a:r>
-          </a:p>
-          <a:p>
-            <a:pPr>
-              <a:defRPr sz="1400">
-                <a:solidFill>
-                  <a:srgbClr val="86868B"/>
-                </a:solidFill>
-              </a:defRPr>
-            </a:pPr>
-            <a:r>
-              <a:t>Execute via global keyboard hotkey or right-click mouse.</a:t>
-            </a:r>
-          </a:p>
-        </p:txBody>
-      </p:sp>
-      <p:sp>
-        <p:nvSpPr>
-          <p:cNvPr id="6" name="Rounded Rectangle 5"/>
-          <p:cNvSpPr/>
-          <p:nvPr/>
-        </p:nvSpPr>
-        <p:spPr>
-          <a:xfrm>
-            <a:off x="7863840" y="2011680"/>
-            <a:ext cx="3383280" cy="3840480"/>
-          </a:xfrm>
-          <a:prstGeom prst="roundRect">
-            <a:avLst/>
-          </a:prstGeom>
-          <a:solidFill>
-            <a:srgbClr val="111111"/>
-          </a:solidFill>
-          <a:ln>
-            <a:solidFill>
-              <a:srgbClr val="282828"/>
-            </a:solidFill>
-          </a:ln>
-        </p:spPr>
-        <p:style>
-          <a:lnRef idx="1">
-            <a:schemeClr val="accent1"/>
-          </a:lnRef>
-          <a:fillRef idx="3">
-            <a:schemeClr val="accent1"/>
-          </a:fillRef>
-          <a:effectRef idx="2">
-            <a:schemeClr val="accent1"/>
-          </a:effectRef>
-          <a:fontRef idx="minor">
-            <a:schemeClr val="lt1"/>
-          </a:fontRef>
-        </p:style>
-        <p:txBody>
-          <a:bodyPr rtlCol="0" anchor="ctr" lIns="274320" tIns="365760" wrap="square"/>
-          <a:lstStyle/>
-          <a:p>
-            <a:pPr algn="ctr">
-              <a:spcAft>
-                <a:spcPts val="1000"/>
-              </a:spcAft>
-              <a:defRPr sz="3600" b="1">
-                <a:solidFill>
-                  <a:srgbClr val="30D158"/>
-                </a:solidFill>
-              </a:defRPr>
-            </a:pPr>
-            <a:r>
-              <a:t>3</a:t>
-            </a:r>
-          </a:p>
-          <a:p>
-            <a:pPr>
-              <a:spcAft>
-                <a:spcPts val="1000"/>
-              </a:spcAft>
-              <a:defRPr sz="2200" b="1">
-                <a:solidFill>
-                  <a:srgbClr val="FFFFFF"/>
-                </a:solidFill>
-              </a:defRPr>
-            </a:pPr>
-            <a:r>
-              <a:t>Route</a:t>
-            </a:r>
-          </a:p>
-          <a:p>
-            <a:pPr>
-              <a:defRPr sz="1400">
-                <a:solidFill>
-                  <a:srgbClr val="86868B"/>
-                </a:solidFill>
-              </a:defRPr>
-            </a:pPr>
-            <a:r>
-              <a:t>Route the relevant search target to get your result.</a:t>
-            </a:r>
-          </a:p>
-        </p:txBody>
-      </p:sp>
+      </p:pic>
     </p:spTree>
   </p:cSld>
   <p:clrMapOvr>
@@ -4757,14 +3342,6 @@
 <file path=ppt/slides/slide6.xml><?xml version="1.0" encoding="utf-8"?>
 <p:sld xmlns:a="http://schemas.openxmlformats.org/drawingml/2006/main" xmlns:p="http://schemas.openxmlformats.org/presentationml/2006/main" xmlns:r="http://schemas.openxmlformats.org/officeDocument/2006/relationships">
   <p:cSld>
-    <p:bg>
-      <p:bgPr>
-        <a:solidFill>
-          <a:srgbClr val="000000"/>
-        </a:solidFill>
-        <a:effectLst/>
-      </p:bgPr>
-    </p:bg>
     <p:spTree>
       <p:nvGrpSpPr>
         <p:cNvPr id="1" name=""/>
@@ -4772,182 +3349,30 @@
         <p:nvPr/>
       </p:nvGrpSpPr>
       <p:grpSpPr/>
-      <p:sp>
-        <p:nvSpPr>
-          <p:cNvPr id="2" name="TextBox 1"/>
-          <p:cNvSpPr txBox="1"/>
+      <p:pic>
+        <p:nvPicPr>
+          <p:cNvPr id="2" name="Picture 1" descr="slide_06.png"/>
+          <p:cNvPicPr>
+            <a:picLocks noChangeAspect="1"/>
+          </p:cNvPicPr>
           <p:nvPr/>
-        </p:nvSpPr>
+        </p:nvPicPr>
+        <p:blipFill>
+          <a:blip r:embed="rId2"/>
+          <a:stretch>
+            <a:fillRect/>
+          </a:stretch>
+        </p:blipFill>
         <p:spPr>
           <a:xfrm>
-            <a:off x="731520" y="457200"/>
-            <a:ext cx="10698480" cy="365760"/>
+            <a:off x="0" y="0"/>
+            <a:ext cx="12191695" cy="6858000"/>
           </a:xfrm>
           <a:prstGeom prst="rect">
             <a:avLst/>
           </a:prstGeom>
-          <a:noFill/>
         </p:spPr>
-        <p:txBody>
-          <a:bodyPr wrap="square">
-            <a:spAutoFit/>
-          </a:bodyPr>
-          <a:lstStyle/>
-          <a:p>
-            <a:pPr>
-              <a:defRPr sz="1100" b="1">
-                <a:solidFill>
-                  <a:srgbClr val="2997FF"/>
-                </a:solidFill>
-                <a:latin typeface="Arial"/>
-              </a:defRPr>
-            </a:pPr>
-            <a:r>
-              <a:t>03 SOLUTION</a:t>
-            </a:r>
-          </a:p>
-        </p:txBody>
-      </p:sp>
-      <p:sp>
-        <p:nvSpPr>
-          <p:cNvPr id="3" name="TextBox 2"/>
-          <p:cNvSpPr txBox="1"/>
-          <p:nvPr/>
-        </p:nvSpPr>
-        <p:spPr>
-          <a:xfrm>
-            <a:off x="731520" y="822960"/>
-            <a:ext cx="10698480" cy="731520"/>
-          </a:xfrm>
-          <a:prstGeom prst="rect">
-            <a:avLst/>
-          </a:prstGeom>
-          <a:noFill/>
-        </p:spPr>
-        <p:txBody>
-          <a:bodyPr wrap="square">
-            <a:spAutoFit/>
-          </a:bodyPr>
-          <a:lstStyle/>
-          <a:p>
-            <a:pPr>
-              <a:defRPr sz="3200" b="1">
-                <a:solidFill>
-                  <a:srgbClr val="FFFFFF"/>
-                </a:solidFill>
-                <a:latin typeface="Arial"/>
-              </a:defRPr>
-            </a:pPr>
-            <a:r>
-              <a:t>Customization &amp; Global Locales</a:t>
-            </a:r>
-          </a:p>
-        </p:txBody>
-      </p:sp>
-      <p:sp>
-        <p:nvSpPr>
-          <p:cNvPr id="4" name="TextBox 3"/>
-          <p:cNvSpPr txBox="1"/>
-          <p:nvPr/>
-        </p:nvSpPr>
-        <p:spPr>
-          <a:xfrm>
-            <a:off x="731520" y="1645920"/>
-            <a:ext cx="10698480" cy="4572000"/>
-          </a:xfrm>
-          <a:prstGeom prst="rect">
-            <a:avLst/>
-          </a:prstGeom>
-          <a:noFill/>
-        </p:spPr>
-        <p:txBody>
-          <a:bodyPr wrap="square">
-            <a:spAutoFit/>
-          </a:bodyPr>
-          <a:lstStyle/>
-          <a:p>
-            <a:pPr>
-              <a:defRPr sz="2000" b="1">
-                <a:solidFill>
-                  <a:srgbClr val="2997FF"/>
-                </a:solidFill>
-              </a:defRPr>
-            </a:pPr>
-            <a:r>
-              <a:t>•  Locale &amp; Region Friendly</a:t>
-            </a:r>
-          </a:p>
-          <a:p>
-            <a:pPr>
-              <a:spcAft>
-                <a:spcPts val="1800"/>
-              </a:spcAft>
-              <a:defRPr sz="1500">
-                <a:solidFill>
-                  <a:srgbClr val="86868B"/>
-                </a:solidFill>
-              </a:defRPr>
-            </a:pPr>
-            <a:r>
-              <a:t>    Search engines and tools support any locale seamlessly: en_IN, en_US, en_GB, en_SA, + any region.</a:t>
-            </a:r>
-          </a:p>
-          <a:p>
-            <a:pPr>
-              <a:defRPr sz="2000" b="1">
-                <a:solidFill>
-                  <a:srgbClr val="2997FF"/>
-                </a:solidFill>
-              </a:defRPr>
-            </a:pPr>
-            <a:r>
-              <a:t>•  Tailored Workflows</a:t>
-            </a:r>
-          </a:p>
-          <a:p>
-            <a:pPr>
-              <a:spcAft>
-                <a:spcPts val="1800"/>
-              </a:spcAft>
-              <a:defRPr sz="1500">
-                <a:solidFill>
-                  <a:srgbClr val="86868B"/>
-                </a:solidFill>
-              </a:defRPr>
-            </a:pPr>
-            <a:r>
-              <a:t>    Customize menu options for Apple Music, Marketing Media Tools, Google Search, and internal databases.</a:t>
-            </a:r>
-          </a:p>
-          <a:p>
-            <a:pPr>
-              <a:defRPr sz="2000" b="1">
-                <a:solidFill>
-                  <a:srgbClr val="2997FF"/>
-                </a:solidFill>
-              </a:defRPr>
-            </a:pPr>
-            <a:r>
-              <a:t>•  Centralized Hub</a:t>
-            </a:r>
-          </a:p>
-          <a:p>
-            <a:pPr>
-              <a:spcAft>
-                <a:spcPts val="1800"/>
-              </a:spcAft>
-              <a:defRPr sz="1500">
-                <a:solidFill>
-                  <a:srgbClr val="86868B"/>
-                </a:solidFill>
-              </a:defRPr>
-            </a:pPr>
-            <a:r>
-              <a:t>    Consolidate scattered bookmarks and enterprise tools into one quick menu.</a:t>
-            </a:r>
-          </a:p>
-        </p:txBody>
-      </p:sp>
+      </p:pic>
     </p:spTree>
   </p:cSld>
   <p:clrMapOvr>
@@ -4959,14 +3384,6 @@
 <file path=ppt/slides/slide7.xml><?xml version="1.0" encoding="utf-8"?>
 <p:sld xmlns:a="http://schemas.openxmlformats.org/drawingml/2006/main" xmlns:p="http://schemas.openxmlformats.org/presentationml/2006/main" xmlns:r="http://schemas.openxmlformats.org/officeDocument/2006/relationships">
   <p:cSld>
-    <p:bg>
-      <p:bgPr>
-        <a:solidFill>
-          <a:srgbClr val="000000"/>
-        </a:solidFill>
-        <a:effectLst/>
-      </p:bgPr>
-    </p:bg>
     <p:spTree>
       <p:nvGrpSpPr>
         <p:cNvPr id="1" name=""/>
@@ -4974,285 +3391,30 @@
         <p:nvPr/>
       </p:nvGrpSpPr>
       <p:grpSpPr/>
-      <p:sp>
-        <p:nvSpPr>
-          <p:cNvPr id="2" name="TextBox 1"/>
-          <p:cNvSpPr txBox="1"/>
+      <p:pic>
+        <p:nvPicPr>
+          <p:cNvPr id="2" name="Picture 1" descr="slide_07.png"/>
+          <p:cNvPicPr>
+            <a:picLocks noChangeAspect="1"/>
+          </p:cNvPicPr>
           <p:nvPr/>
-        </p:nvSpPr>
+        </p:nvPicPr>
+        <p:blipFill>
+          <a:blip r:embed="rId2"/>
+          <a:stretch>
+            <a:fillRect/>
+          </a:stretch>
+        </p:blipFill>
         <p:spPr>
           <a:xfrm>
-            <a:off x="731520" y="457200"/>
-            <a:ext cx="10698480" cy="365760"/>
+            <a:off x="0" y="0"/>
+            <a:ext cx="12191695" cy="6858000"/>
           </a:xfrm>
           <a:prstGeom prst="rect">
             <a:avLst/>
           </a:prstGeom>
-          <a:noFill/>
         </p:spPr>
-        <p:txBody>
-          <a:bodyPr wrap="square">
-            <a:spAutoFit/>
-          </a:bodyPr>
-          <a:lstStyle/>
-          <a:p>
-            <a:pPr>
-              <a:defRPr sz="1100" b="1">
-                <a:solidFill>
-                  <a:srgbClr val="2997FF"/>
-                </a:solidFill>
-                <a:latin typeface="Arial"/>
-              </a:defRPr>
-            </a:pPr>
-            <a:r>
-              <a:t>04 TIME SAVED</a:t>
-            </a:r>
-          </a:p>
-        </p:txBody>
-      </p:sp>
-      <p:sp>
-        <p:nvSpPr>
-          <p:cNvPr id="3" name="TextBox 2"/>
-          <p:cNvSpPr txBox="1"/>
-          <p:nvPr/>
-        </p:nvSpPr>
-        <p:spPr>
-          <a:xfrm>
-            <a:off x="731520" y="822960"/>
-            <a:ext cx="10698480" cy="731520"/>
-          </a:xfrm>
-          <a:prstGeom prst="rect">
-            <a:avLst/>
-          </a:prstGeom>
-          <a:noFill/>
-        </p:spPr>
-        <p:txBody>
-          <a:bodyPr wrap="square">
-            <a:spAutoFit/>
-          </a:bodyPr>
-          <a:lstStyle/>
-          <a:p>
-            <a:pPr>
-              <a:defRPr sz="3200" b="1">
-                <a:solidFill>
-                  <a:srgbClr val="FFFFFF"/>
-                </a:solidFill>
-                <a:latin typeface="Arial"/>
-              </a:defRPr>
-            </a:pPr>
-            <a:r>
-              <a:t>The numbers speak.</a:t>
-            </a:r>
-          </a:p>
-        </p:txBody>
-      </p:sp>
-      <p:sp>
-        <p:nvSpPr>
-          <p:cNvPr id="4" name="Rounded Rectangle 3"/>
-          <p:cNvSpPr/>
-          <p:nvPr/>
-        </p:nvSpPr>
-        <p:spPr>
-          <a:xfrm>
-            <a:off x="731520" y="2011680"/>
-            <a:ext cx="3383280" cy="3840480"/>
-          </a:xfrm>
-          <a:prstGeom prst="roundRect">
-            <a:avLst/>
-          </a:prstGeom>
-          <a:solidFill>
-            <a:srgbClr val="111111"/>
-          </a:solidFill>
-          <a:ln>
-            <a:solidFill>
-              <a:srgbClr val="282828"/>
-            </a:solidFill>
-          </a:ln>
-        </p:spPr>
-        <p:style>
-          <a:lnRef idx="1">
-            <a:schemeClr val="accent1"/>
-          </a:lnRef>
-          <a:fillRef idx="3">
-            <a:schemeClr val="accent1"/>
-          </a:fillRef>
-          <a:effectRef idx="2">
-            <a:schemeClr val="accent1"/>
-          </a:effectRef>
-          <a:fontRef idx="minor">
-            <a:schemeClr val="lt1"/>
-          </a:fontRef>
-        </p:style>
-        <p:txBody>
-          <a:bodyPr rtlCol="0" anchor="ctr" lIns="274320" tIns="457200" wrap="square"/>
-          <a:lstStyle/>
-          <a:p>
-            <a:pPr algn="ctr">
-              <a:spcAft>
-                <a:spcPts val="1400"/>
-              </a:spcAft>
-              <a:defRPr sz="2800" b="1">
-                <a:solidFill>
-                  <a:srgbClr val="30D158"/>
-                </a:solidFill>
-              </a:defRPr>
-            </a:pPr>
-            <a:r>
-              <a:t>8.5 Hours</a:t>
-            </a:r>
-          </a:p>
-          <a:p>
-            <a:pPr>
-              <a:defRPr sz="1500">
-                <a:solidFill>
-                  <a:srgbClr val="86868B"/>
-                </a:solidFill>
-              </a:defRPr>
-            </a:pPr>
-            <a:r>
-              <a:t>Saved per analyst / month</a:t>
-            </a:r>
-          </a:p>
-        </p:txBody>
-      </p:sp>
-      <p:sp>
-        <p:nvSpPr>
-          <p:cNvPr id="5" name="Rounded Rectangle 4"/>
-          <p:cNvSpPr/>
-          <p:nvPr/>
-        </p:nvSpPr>
-        <p:spPr>
-          <a:xfrm>
-            <a:off x="4297680" y="2011680"/>
-            <a:ext cx="3383280" cy="3840480"/>
-          </a:xfrm>
-          <a:prstGeom prst="roundRect">
-            <a:avLst/>
-          </a:prstGeom>
-          <a:solidFill>
-            <a:srgbClr val="111111"/>
-          </a:solidFill>
-          <a:ln>
-            <a:solidFill>
-              <a:srgbClr val="282828"/>
-            </a:solidFill>
-          </a:ln>
-        </p:spPr>
-        <p:style>
-          <a:lnRef idx="1">
-            <a:schemeClr val="accent1"/>
-          </a:lnRef>
-          <a:fillRef idx="3">
-            <a:schemeClr val="accent1"/>
-          </a:fillRef>
-          <a:effectRef idx="2">
-            <a:schemeClr val="accent1"/>
-          </a:effectRef>
-          <a:fontRef idx="minor">
-            <a:schemeClr val="lt1"/>
-          </a:fontRef>
-        </p:style>
-        <p:txBody>
-          <a:bodyPr rtlCol="0" anchor="ctr" lIns="274320" tIns="457200" wrap="square"/>
-          <a:lstStyle/>
-          <a:p>
-            <a:pPr algn="ctr">
-              <a:spcAft>
-                <a:spcPts val="1400"/>
-              </a:spcAft>
-              <a:defRPr sz="2800" b="1">
-                <a:solidFill>
-                  <a:srgbClr val="30D158"/>
-                </a:solidFill>
-              </a:defRPr>
-            </a:pPr>
-            <a:r>
-              <a:t>94% Reduction</a:t>
-            </a:r>
-          </a:p>
-          <a:p>
-            <a:pPr>
-              <a:defRPr sz="1500">
-                <a:solidFill>
-                  <a:srgbClr val="86868B"/>
-                </a:solidFill>
-              </a:defRPr>
-            </a:pPr>
-            <a:r>
-              <a:t>Search time cut from 30s → 2s</a:t>
-            </a:r>
-          </a:p>
-        </p:txBody>
-      </p:sp>
-      <p:sp>
-        <p:nvSpPr>
-          <p:cNvPr id="6" name="Rounded Rectangle 5"/>
-          <p:cNvSpPr/>
-          <p:nvPr/>
-        </p:nvSpPr>
-        <p:spPr>
-          <a:xfrm>
-            <a:off x="7863840" y="2011680"/>
-            <a:ext cx="3383280" cy="3840480"/>
-          </a:xfrm>
-          <a:prstGeom prst="roundRect">
-            <a:avLst/>
-          </a:prstGeom>
-          <a:solidFill>
-            <a:srgbClr val="111111"/>
-          </a:solidFill>
-          <a:ln>
-            <a:solidFill>
-              <a:srgbClr val="282828"/>
-            </a:solidFill>
-          </a:ln>
-        </p:spPr>
-        <p:style>
-          <a:lnRef idx="1">
-            <a:schemeClr val="accent1"/>
-          </a:lnRef>
-          <a:fillRef idx="3">
-            <a:schemeClr val="accent1"/>
-          </a:fillRef>
-          <a:effectRef idx="2">
-            <a:schemeClr val="accent1"/>
-          </a:effectRef>
-          <a:fontRef idx="minor">
-            <a:schemeClr val="lt1"/>
-          </a:fontRef>
-        </p:style>
-        <p:txBody>
-          <a:bodyPr rtlCol="0" anchor="ctr" lIns="274320" tIns="457200" wrap="square"/>
-          <a:lstStyle/>
-          <a:p>
-            <a:pPr algn="ctr">
-              <a:spcAft>
-                <a:spcPts val="1400"/>
-              </a:spcAft>
-              <a:defRPr sz="2800" b="1">
-                <a:solidFill>
-                  <a:srgbClr val="30D158"/>
-                </a:solidFill>
-              </a:defRPr>
-            </a:pPr>
-            <a:r>
-              <a:t>100% Native</a:t>
-            </a:r>
-          </a:p>
-          <a:p>
-            <a:pPr>
-              <a:defRPr sz="1500">
-                <a:solidFill>
-                  <a:srgbClr val="86868B"/>
-                </a:solidFill>
-              </a:defRPr>
-            </a:pPr>
-            <a:r>
-              <a:t>Zero dependencies, fully accessible</a:t>
-            </a:r>
-          </a:p>
-        </p:txBody>
-      </p:sp>
+      </p:pic>
     </p:spTree>
   </p:cSld>
   <p:clrMapOvr>
@@ -5264,14 +3426,6 @@
 <file path=ppt/slides/slide8.xml><?xml version="1.0" encoding="utf-8"?>
 <p:sld xmlns:a="http://schemas.openxmlformats.org/drawingml/2006/main" xmlns:p="http://schemas.openxmlformats.org/presentationml/2006/main" xmlns:r="http://schemas.openxmlformats.org/officeDocument/2006/relationships">
   <p:cSld>
-    <p:bg>
-      <p:bgPr>
-        <a:solidFill>
-          <a:srgbClr val="000000"/>
-        </a:solidFill>
-        <a:effectLst/>
-      </p:bgPr>
-    </p:bg>
     <p:spTree>
       <p:nvGrpSpPr>
         <p:cNvPr id="1" name=""/>
@@ -5279,321 +3433,30 @@
         <p:nvPr/>
       </p:nvGrpSpPr>
       <p:grpSpPr/>
-      <p:sp>
-        <p:nvSpPr>
-          <p:cNvPr id="2" name="TextBox 1"/>
-          <p:cNvSpPr txBox="1"/>
+      <p:pic>
+        <p:nvPicPr>
+          <p:cNvPr id="2" name="Picture 1" descr="slide_08.png"/>
+          <p:cNvPicPr>
+            <a:picLocks noChangeAspect="1"/>
+          </p:cNvPicPr>
           <p:nvPr/>
-        </p:nvSpPr>
+        </p:nvPicPr>
+        <p:blipFill>
+          <a:blip r:embed="rId2"/>
+          <a:stretch>
+            <a:fillRect/>
+          </a:stretch>
+        </p:blipFill>
         <p:spPr>
           <a:xfrm>
-            <a:off x="731520" y="457200"/>
-            <a:ext cx="10698480" cy="365760"/>
+            <a:off x="0" y="0"/>
+            <a:ext cx="12191695" cy="6858000"/>
           </a:xfrm>
           <a:prstGeom prst="rect">
             <a:avLst/>
           </a:prstGeom>
-          <a:noFill/>
         </p:spPr>
-        <p:txBody>
-          <a:bodyPr wrap="square">
-            <a:spAutoFit/>
-          </a:bodyPr>
-          <a:lstStyle/>
-          <a:p>
-            <a:pPr>
-              <a:defRPr sz="1100" b="1">
-                <a:solidFill>
-                  <a:srgbClr val="2997FF"/>
-                </a:solidFill>
-                <a:latin typeface="Arial"/>
-              </a:defRPr>
-            </a:pPr>
-            <a:r>
-              <a:t>05 PILOT FEEDBACK</a:t>
-            </a:r>
-          </a:p>
-        </p:txBody>
-      </p:sp>
-      <p:sp>
-        <p:nvSpPr>
-          <p:cNvPr id="3" name="TextBox 2"/>
-          <p:cNvSpPr txBox="1"/>
-          <p:nvPr/>
-        </p:nvSpPr>
-        <p:spPr>
-          <a:xfrm>
-            <a:off x="731520" y="822960"/>
-            <a:ext cx="10698480" cy="731520"/>
-          </a:xfrm>
-          <a:prstGeom prst="rect">
-            <a:avLst/>
-          </a:prstGeom>
-          <a:noFill/>
-        </p:spPr>
-        <p:txBody>
-          <a:bodyPr wrap="square">
-            <a:spAutoFit/>
-          </a:bodyPr>
-          <a:lstStyle/>
-          <a:p>
-            <a:pPr>
-              <a:defRPr sz="3200" b="1">
-                <a:solidFill>
-                  <a:srgbClr val="FFFFFF"/>
-                </a:solidFill>
-                <a:latin typeface="Arial"/>
-              </a:defRPr>
-            </a:pPr>
-            <a:r>
-              <a:t>What analysts are saying.</a:t>
-            </a:r>
-          </a:p>
-        </p:txBody>
-      </p:sp>
-      <p:sp>
-        <p:nvSpPr>
-          <p:cNvPr id="4" name="Rounded Rectangle 3"/>
-          <p:cNvSpPr/>
-          <p:nvPr/>
-        </p:nvSpPr>
-        <p:spPr>
-          <a:xfrm>
-            <a:off x="731520" y="2011680"/>
-            <a:ext cx="3383280" cy="3840480"/>
-          </a:xfrm>
-          <a:prstGeom prst="roundRect">
-            <a:avLst/>
-          </a:prstGeom>
-          <a:solidFill>
-            <a:srgbClr val="111111"/>
-          </a:solidFill>
-          <a:ln>
-            <a:solidFill>
-              <a:srgbClr val="282828"/>
-            </a:solidFill>
-          </a:ln>
-        </p:spPr>
-        <p:style>
-          <a:lnRef idx="1">
-            <a:schemeClr val="accent1"/>
-          </a:lnRef>
-          <a:fillRef idx="3">
-            <a:schemeClr val="accent1"/>
-          </a:fillRef>
-          <a:effectRef idx="2">
-            <a:schemeClr val="accent1"/>
-          </a:effectRef>
-          <a:fontRef idx="minor">
-            <a:schemeClr val="lt1"/>
-          </a:fontRef>
-        </p:style>
-        <p:txBody>
-          <a:bodyPr rtlCol="0" anchor="ctr" lIns="274320" tIns="365760" wrap="square"/>
-          <a:lstStyle/>
-          <a:p>
-            <a:pPr algn="ctr">
-              <a:spcAft>
-                <a:spcPts val="2000"/>
-              </a:spcAft>
-              <a:defRPr sz="1400" i="1">
-                <a:solidFill>
-                  <a:srgbClr val="FFFFFF"/>
-                </a:solidFill>
-              </a:defRPr>
-            </a:pPr>
-            <a:r>
-              <a:t>"Saved me at least 15 minutes of tab-hunting every day. Indispensable for high-volume research."</a:t>
-            </a:r>
-          </a:p>
-          <a:p>
-            <a:pPr>
-              <a:defRPr sz="1400" b="1">
-                <a:solidFill>
-                  <a:srgbClr val="2997FF"/>
-                </a:solidFill>
-              </a:defRPr>
-            </a:pPr>
-            <a:r>
-              <a:t>Senior Data Analyst</a:t>
-            </a:r>
-          </a:p>
-          <a:p>
-            <a:pPr>
-              <a:defRPr sz="1200">
-                <a:solidFill>
-                  <a:srgbClr val="86868B"/>
-                </a:solidFill>
-              </a:defRPr>
-            </a:pPr>
-            <a:r>
-              <a:t>Media Research Team</a:t>
-            </a:r>
-          </a:p>
-        </p:txBody>
-      </p:sp>
-      <p:sp>
-        <p:nvSpPr>
-          <p:cNvPr id="5" name="Rounded Rectangle 4"/>
-          <p:cNvSpPr/>
-          <p:nvPr/>
-        </p:nvSpPr>
-        <p:spPr>
-          <a:xfrm>
-            <a:off x="4297680" y="2011680"/>
-            <a:ext cx="3383280" cy="3840480"/>
-          </a:xfrm>
-          <a:prstGeom prst="roundRect">
-            <a:avLst/>
-          </a:prstGeom>
-          <a:solidFill>
-            <a:srgbClr val="111111"/>
-          </a:solidFill>
-          <a:ln>
-            <a:solidFill>
-              <a:srgbClr val="282828"/>
-            </a:solidFill>
-          </a:ln>
-        </p:spPr>
-        <p:style>
-          <a:lnRef idx="1">
-            <a:schemeClr val="accent1"/>
-          </a:lnRef>
-          <a:fillRef idx="3">
-            <a:schemeClr val="accent1"/>
-          </a:fillRef>
-          <a:effectRef idx="2">
-            <a:schemeClr val="accent1"/>
-          </a:effectRef>
-          <a:fontRef idx="minor">
-            <a:schemeClr val="lt1"/>
-          </a:fontRef>
-        </p:style>
-        <p:txBody>
-          <a:bodyPr rtlCol="0" anchor="ctr" lIns="274320" tIns="365760" wrap="square"/>
-          <a:lstStyle/>
-          <a:p>
-            <a:pPr algn="ctr">
-              <a:spcAft>
-                <a:spcPts val="2000"/>
-              </a:spcAft>
-              <a:defRPr sz="1400" i="1">
-                <a:solidFill>
-                  <a:srgbClr val="FFFFFF"/>
-                </a:solidFill>
-              </a:defRPr>
-            </a:pPr>
-            <a:r>
-              <a:t>"VoiceOver navigation is flawless. First tool that treats accessibility as a core feature."</a:t>
-            </a:r>
-          </a:p>
-          <a:p>
-            <a:pPr>
-              <a:defRPr sz="1400" b="1">
-                <a:solidFill>
-                  <a:srgbClr val="2997FF"/>
-                </a:solidFill>
-              </a:defRPr>
-            </a:pPr>
-            <a:r>
-              <a:t>Accessibility Specialist</a:t>
-            </a:r>
-          </a:p>
-          <a:p>
-            <a:pPr>
-              <a:defRPr sz="1200">
-                <a:solidFill>
-                  <a:srgbClr val="86868B"/>
-                </a:solidFill>
-              </a:defRPr>
-            </a:pPr>
-            <a:r>
-              <a:t>Product Operations</a:t>
-            </a:r>
-          </a:p>
-        </p:txBody>
-      </p:sp>
-      <p:sp>
-        <p:nvSpPr>
-          <p:cNvPr id="6" name="Rounded Rectangle 5"/>
-          <p:cNvSpPr/>
-          <p:nvPr/>
-        </p:nvSpPr>
-        <p:spPr>
-          <a:xfrm>
-            <a:off x="7863840" y="2011680"/>
-            <a:ext cx="3383280" cy="3840480"/>
-          </a:xfrm>
-          <a:prstGeom prst="roundRect">
-            <a:avLst/>
-          </a:prstGeom>
-          <a:solidFill>
-            <a:srgbClr val="111111"/>
-          </a:solidFill>
-          <a:ln>
-            <a:solidFill>
-              <a:srgbClr val="282828"/>
-            </a:solidFill>
-          </a:ln>
-        </p:spPr>
-        <p:style>
-          <a:lnRef idx="1">
-            <a:schemeClr val="accent1"/>
-          </a:lnRef>
-          <a:fillRef idx="3">
-            <a:schemeClr val="accent1"/>
-          </a:fillRef>
-          <a:effectRef idx="2">
-            <a:schemeClr val="accent1"/>
-          </a:effectRef>
-          <a:fontRef idx="minor">
-            <a:schemeClr val="lt1"/>
-          </a:fontRef>
-        </p:style>
-        <p:txBody>
-          <a:bodyPr rtlCol="0" anchor="ctr" lIns="274320" tIns="365760" wrap="square"/>
-          <a:lstStyle/>
-          <a:p>
-            <a:pPr algn="ctr">
-              <a:spcAft>
-                <a:spcPts val="2000"/>
-              </a:spcAft>
-              <a:defRPr sz="1400" i="1">
-                <a:solidFill>
-                  <a:srgbClr val="FFFFFF"/>
-                </a:solidFill>
-              </a:defRPr>
-            </a:pPr>
-            <a:r>
-              <a:t>"Sanitizing URL parameters automatically saved our team from broken enterprise tool links."</a:t>
-            </a:r>
-          </a:p>
-          <a:p>
-            <a:pPr>
-              <a:defRPr sz="1400" b="1">
-                <a:solidFill>
-                  <a:srgbClr val="2997FF"/>
-                </a:solidFill>
-              </a:defRPr>
-            </a:pPr>
-            <a:r>
-              <a:t>Operations Lead</a:t>
-            </a:r>
-          </a:p>
-          <a:p>
-            <a:pPr>
-              <a:defRPr sz="1200">
-                <a:solidFill>
-                  <a:srgbClr val="86868B"/>
-                </a:solidFill>
-              </a:defRPr>
-            </a:pPr>
-            <a:r>
-              <a:t>Workflow Engineering</a:t>
-            </a:r>
-          </a:p>
-        </p:txBody>
-      </p:sp>
+      </p:pic>
     </p:spTree>
   </p:cSld>
   <p:clrMapOvr>
@@ -5605,14 +3468,6 @@
 <file path=ppt/slides/slide9.xml><?xml version="1.0" encoding="utf-8"?>
 <p:sld xmlns:a="http://schemas.openxmlformats.org/drawingml/2006/main" xmlns:p="http://schemas.openxmlformats.org/presentationml/2006/main" xmlns:r="http://schemas.openxmlformats.org/officeDocument/2006/relationships">
   <p:cSld>
-    <p:bg>
-      <p:bgPr>
-        <a:solidFill>
-          <a:srgbClr val="000000"/>
-        </a:solidFill>
-        <a:effectLst/>
-      </p:bgPr>
-    </p:bg>
     <p:spTree>
       <p:nvGrpSpPr>
         <p:cNvPr id="1" name=""/>
@@ -5620,56 +3475,30 @@
         <p:nvPr/>
       </p:nvGrpSpPr>
       <p:grpSpPr/>
-      <p:sp>
-        <p:nvSpPr>
-          <p:cNvPr id="2" name="TextBox 1"/>
-          <p:cNvSpPr txBox="1"/>
+      <p:pic>
+        <p:nvPicPr>
+          <p:cNvPr id="2" name="Picture 1" descr="slide_09.png"/>
+          <p:cNvPicPr>
+            <a:picLocks noChangeAspect="1"/>
+          </p:cNvPicPr>
           <p:nvPr/>
-        </p:nvSpPr>
+        </p:nvPicPr>
+        <p:blipFill>
+          <a:blip r:embed="rId2"/>
+          <a:stretch>
+            <a:fillRect/>
+          </a:stretch>
+        </p:blipFill>
         <p:spPr>
           <a:xfrm>
-            <a:off x="914400" y="2286000"/>
-            <a:ext cx="10332720" cy="2743200"/>
+            <a:off x="0" y="0"/>
+            <a:ext cx="12191695" cy="6858000"/>
           </a:xfrm>
           <a:prstGeom prst="rect">
             <a:avLst/>
           </a:prstGeom>
-          <a:noFill/>
         </p:spPr>
-        <p:txBody>
-          <a:bodyPr wrap="square">
-            <a:spAutoFit/>
-          </a:bodyPr>
-          <a:lstStyle/>
-          <a:p>
-            <a:pPr>
-              <a:defRPr sz="4400" b="1">
-                <a:solidFill>
-                  <a:srgbClr val="FFFFFF"/>
-                </a:solidFill>
-              </a:defRPr>
-            </a:pPr>
-            <a:r>
-              <a:t>Fluid. Inclusive. Native. Universal.</a:t>
-            </a:r>
-          </a:p>
-          <a:p>
-            <a:pPr>
-              <a:spcBef>
-                <a:spcPts val="1600"/>
-              </a:spcBef>
-              <a:defRPr sz="2200">
-                <a:solidFill>
-                  <a:srgbClr val="2997FF"/>
-                </a:solidFill>
-              </a:defRPr>
-            </a:pPr>
-            <a:r>
-              <a:t>Ready for immediate deployment across analyst workstations.</a:t>
-            </a:r>
-          </a:p>
-        </p:txBody>
-      </p:sp>
+      </p:pic>
     </p:spTree>
   </p:cSld>
   <p:clrMapOvr>

</xml_diff>